<commit_message>
Align research agent with design feedback
</commit_message>
<xml_diff>
--- a/Unit11/Development Project-Individual Project Presentation/Academic-Research-Agent-Presentation.pptx
+++ b/Unit11/Development Project-Individual Project Presentation/Academic-Research-Agent-Presentation.pptx
@@ -3237,154 +3237,147 @@
           </a:p>
         </p:txBody>
       </p:sp>
-      <p:sp>
-        <p:nvSpPr>
-          <p:cNvPr id="3" name="Content Placeholder 2"/>
-          <p:cNvSpPr>
-            <a:spLocks noGrp="1"/>
-          </p:cNvSpPr>
-          <p:nvPr>
-            <p:ph idx="1"/>
-          </p:nvPr>
-        </p:nvSpPr>
-        <p:spPr/>
-        <p:txBody>
-          <a:bodyPr/>
-          <a:lstStyle/>
-          <a:p>
-            <a:pPr lvl="0" indent="0" marL="0">
-              <a:buNone/>
-            </a:pPr>
-            <a:r>
-              <a:rPr b="1"/>
-              <a:t>Strengths:</a:t>
-            </a:r>
-            <a:r>
-              <a:rPr/>
-              <a:t> modular boundaries, reproducibility, provenance, graceful fallback and bounded autonomy.</a:t>
-            </a:r>
-          </a:p>
-          <a:p>
-            <a:pPr lvl="0" indent="0" marL="0">
-              <a:buNone/>
-            </a:pPr>
-            <a:r>
-              <a:rPr b="1"/>
-              <a:t>Limitations:</a:t>
-            </a:r>
-            <a:r>
-              <a:rPr/>
-              <a:t> keyword ranking is semantically shallow; citation counts favour older work; the fixture proves behaviour rather than real-world source quality; no user study was performed.</a:t>
-            </a:r>
-          </a:p>
-          <a:p>
-            <a:pPr lvl="0" indent="0" marL="0">
-              <a:buNone/>
-            </a:pPr>
-            <a:r>
-              <a:rPr b="1"/>
-              <a:t>Next steps:</a:t>
-            </a:r>
-            <a:r>
-              <a:rPr/>
-              <a:t> manually labelled relevance set, precision/recall measures, DOI verification, model comparison, prompt-injection tests and researcher usability evaluation.</a:t>
-            </a:r>
-          </a:p>
-          <a:p>
-            <a:pPr lvl="0" indent="0" marL="0">
-              <a:buNone/>
-            </a:pPr>
-            <a:r>
-              <a:rPr b="1"/>
-              <a:t>Selected references</a:t>
-            </a:r>
-          </a:p>
-          <a:p>
-            <a:pPr lvl="0" indent="0" marL="0">
-              <a:buNone/>
-            </a:pPr>
-            <a:r>
-              <a:rPr/>
-              <a:t>Bandi, A. </a:t>
-            </a:r>
-            <a:r>
-              <a:rPr i="1"/>
-              <a:t>et al.</a:t>
-            </a:r>
-            <a:r>
-              <a:rPr/>
-              <a:t> (2025) ‘The rise of agentic AI’, </a:t>
-            </a:r>
-            <a:r>
-              <a:rPr i="1"/>
-              <a:t>Future Internet</a:t>
-            </a:r>
-            <a:r>
-              <a:rPr/>
-              <a:t>, 17(9), 404.</a:t>
-            </a:r>
-          </a:p>
-          <a:p>
-            <a:pPr lvl="0" indent="0" marL="0">
-              <a:buNone/>
-            </a:pPr>
-            <a:r>
-              <a:rPr/>
-              <a:t>Lewis, P. </a:t>
-            </a:r>
-            <a:r>
-              <a:rPr i="1"/>
-              <a:t>et al.</a:t>
-            </a:r>
-            <a:r>
-              <a:rPr/>
-              <a:t> (2020) ‘Retrieval-augmented generation’, </a:t>
-            </a:r>
-            <a:r>
-              <a:rPr i="1"/>
-              <a:t>NeurIPS</a:t>
-            </a:r>
-            <a:r>
-              <a:rPr/>
-              <a:t>, 33, pp. 9459–9474.</a:t>
-            </a:r>
-          </a:p>
-          <a:p>
-            <a:pPr lvl="0" indent="0" marL="0">
-              <a:buNone/>
-            </a:pPr>
-            <a:r>
-              <a:rPr/>
-              <a:t>Russell, S. and Norvig, P. (2021) </a:t>
-            </a:r>
-            <a:r>
-              <a:rPr i="1"/>
-              <a:t>Artificial Intelligence: A Modern Approach</a:t>
-            </a:r>
-            <a:r>
-              <a:rPr/>
-              <a:t>. 4th edn. Pearson.</a:t>
-            </a:r>
-          </a:p>
-          <a:p>
-            <a:pPr lvl="0" indent="0" marL="0">
-              <a:buNone/>
-            </a:pPr>
-            <a:r>
-              <a:rPr/>
-              <a:t>OpenAlex (no date) </a:t>
-            </a:r>
-            <a:r>
-              <a:rPr i="1"/>
-              <a:t>API documentation</a:t>
-            </a:r>
-            <a:r>
-              <a:rPr/>
-              <a:t>. https://docs.openalex.org/</a:t>
-            </a:r>
-          </a:p>
-        </p:txBody>
-      </p:sp>
+      <mc:AlternateContent xmlns:mc="http://schemas.openxmlformats.org/markup-compatibility/2006">
+        <mc:Choice xmlns:a14="http://schemas.microsoft.com/office/drawing/2010/main" Requires="a14">
+          <p:sp>
+            <p:nvSpPr>
+              <p:cNvPr id="3" name="Content Placeholder 2"/>
+              <p:cNvSpPr>
+                <a:spLocks noGrp="1"/>
+              </p:cNvSpPr>
+              <p:nvPr>
+                <p:ph idx="1"/>
+              </p:nvPr>
+            </p:nvSpPr>
+            <p:spPr/>
+            <p:txBody>
+              <a:bodyPr/>
+              <a:lstStyle/>
+              <a:p>
+                <a:pPr lvl="0" indent="0" marL="0">
+                  <a:buNone/>
+                </a:pPr>
+                <a:r>
+                  <a:rPr b="1"/>
+                  <a:t>Strengths:</a:t>
+                </a:r>
+                <a:r>
+                  <a:rPr/>
+                  <a:t> modular, reproducible, traceable and bounded.</a:t>
+                </a:r>
+              </a:p>
+              <a:p>
+                <a:pPr lvl="0" indent="0" marL="0">
+                  <a:buNone/>
+                </a:pPr>
+                <a:r>
+                  <a:rPr b="1"/>
+                  <a:t>Limits:</a:t>
+                </a:r>
+                <a:r>
+                  <a:rPr/>
+                  <a:t> lexical ranking, age-biased citations, OpenAlex only, synthetic fixture and no model/user benchmark.</a:t>
+                </a:r>
+              </a:p>
+              <a:p>
+                <a:pPr lvl="0" indent="0" marL="0">
+                  <a:buNone/>
+                </a:pPr>
+                <a:r>
+                  <a:rPr b="1"/>
+                  <a:t>Feedback-led evaluation:</a:t>
+                </a:r>
+              </a:p>
+              <a:p>
+                <a:pPr lvl="0"/>
+                <a:r>
+                  <a:rPr/>
+                  <a:t>Labelled queries: P@</a:t>
+                </a:r>
+                <a14:m>
+                  <m:oMath xmlns:m="http://schemas.openxmlformats.org/officeDocument/2006/math">
+                    <m:r>
+                      <m:t>k</m:t>
+                    </m:r>
+                  </m:oMath>
+                </a14:m>
+                <a:r>
+                  <a:rPr/>
+                  <a:t>, nDCG@</a:t>
+                </a:r>
+                <a14:m>
+                  <m:oMath xmlns:m="http://schemas.openxmlformats.org/officeDocument/2006/math">
+                    <m:r>
+                      <m:t>k</m:t>
+                    </m:r>
+                  </m:oMath>
+                </a14:m>
+                <a:r>
+                  <a:rPr/>
+                  <a:t>, DOI/source validity and abstention</a:t>
+                </a:r>
+              </a:p>
+              <a:p>
+                <a:pPr lvl="0"/>
+                <a:r>
+                  <a:rPr/>
+                  <a:t>Models: p50/p95 latency, memory, tokens and cost</a:t>
+                </a:r>
+              </a:p>
+              <a:p>
+                <a:pPr lvl="0" indent="0" marL="0">
+                  <a:buNone/>
+                </a:pPr>
+                <a:r>
+                  <a:rPr b="1"/>
+                  <a:t>Conclusion:</a:t>
+                </a:r>
+                <a:r>
+                  <a:rPr/>
+                  <a:t> goal-plan-act-output with human oversight.</a:t>
+                </a:r>
+              </a:p>
+              <a:p>
+                <a:pPr lvl="0" indent="0" marL="0">
+                  <a:buNone/>
+                </a:pPr>
+                <a:r>
+                  <a:rPr b="1"/>
+                  <a:t>Sources:</a:t>
+                </a:r>
+                <a:r>
+                  <a:rPr/>
+                  <a:t> Peffers </a:t>
+                </a:r>
+                <a:r>
+                  <a:rPr i="1"/>
+                  <a:t>et al.</a:t>
+                </a:r>
+                <a:r>
+                  <a:rPr/>
+                  <a:t> (2007); Lewis </a:t>
+                </a:r>
+                <a:r>
+                  <a:rPr i="1"/>
+                  <a:t>et al.</a:t>
+                </a:r>
+                <a:r>
+                  <a:rPr/>
+                  <a:t> (2020); Russell and Norvig (2021); Bandi </a:t>
+                </a:r>
+                <a:r>
+                  <a:rPr i="1"/>
+                  <a:t>et al.</a:t>
+                </a:r>
+                <a:r>
+                  <a:rPr/>
+                  <a:t> (2025). Full references: transcript/README.</a:t>
+                </a:r>
+              </a:p>
+            </p:txBody>
+          </p:sp>
+        </mc:Choice>
+      </mc:AlternateContent>
     </p:spTree>
   </p:cSld>
 </p:sld>
@@ -3486,6 +3479,21 @@
             <a:r>
               <a:rPr/>
               <a:t>Bound retries and fail safely when a model or network is unavailable</a:t>
+            </a:r>
+          </a:p>
+          <a:p>
+            <a:pPr lvl="0"/>
+            <a:r>
+              <a:rPr/>
+              <a:t>Design Science frames the artefact and its evaluation (Peffers </a:t>
+            </a:r>
+            <a:r>
+              <a:rPr i="1"/>
+              <a:t>et al.</a:t>
+            </a:r>
+            <a:r>
+              <a:rPr/>
+              <a:t>, 2007)</a:t>
             </a:r>
           </a:p>
         </p:txBody>
@@ -3638,7 +3646,7 @@
                       </a:pPr>
                       <a:r>
                         <a:rPr/>
-                        <a:t>Scholarly search APIs</a:t>
+                        <a:t>arXiv, OpenAlex and CORE connectors</a:t>
                       </a:r>
                     </a:p>
                   </a:txBody>
@@ -3653,7 +3661,7 @@
                       </a:pPr>
                       <a:r>
                         <a:rPr/>
-                        <a:t>OpenAlex API and reproducible offline fixture</a:t>
+                        <a:t>OpenAlex implemented; other connectors remain future work</a:t>
                       </a:r>
                     </a:p>
                   </a:txBody>
@@ -3686,6 +3694,38 @@
                       <a:r>
                         <a:rPr/>
                         <a:t>Four typed components with explicit hand-offs</a:t>
+                      </a:r>
+                    </a:p>
+                  </a:txBody>
+                </a:tc>
+              </a:tr>
+              <a:tr h="0">
+                <a:tc>
+                  <a:txBody>
+                    <a:bodyPr/>
+                    <a:lstStyle/>
+                    <a:p>
+                      <a:pPr lvl="0" indent="0" marL="0">
+                        <a:buNone/>
+                      </a:pPr>
+                      <a:r>
+                        <a:rPr/>
+                        <a:t>LangGraph, Pydantic, HTTPX, Tenacity</a:t>
+                      </a:r>
+                    </a:p>
+                  </a:txBody>
+                </a:tc>
+                <a:tc>
+                  <a:txBody>
+                    <a:bodyPr/>
+                    <a:lstStyle/>
+                    <a:p>
+                      <a:pPr lvl="0" indent="0" marL="0">
+                        <a:buNone/>
+                      </a:pPr>
+                      <a:r>
+                        <a:rPr/>
+                        <a:t>Standard-library protocols and typed dataclasses minimise dependencies</a:t>
                       </a:r>
                     </a:p>
                   </a:txBody>
@@ -3940,6 +3980,13 @@
             </a:r>
           </a:p>
           <a:p>
+            <a:pPr lvl="0"/>
+            <a:r>
+              <a:rPr/>
+              <a:t>Autonomy is bounded at workflow level; deterministic specialists are not independent goal-seeking agents</a:t>
+            </a:r>
+          </a:p>
+          <a:p>
             <a:pPr lvl="0" indent="0">
               <a:buNone/>
             </a:pPr>
@@ -4204,6 +4251,13 @@
               <a:t>Risks remain: coverage gaps, missing abstracts and citation-age bias</a:t>
             </a:r>
           </a:p>
+          <a:p>
+            <a:pPr lvl="0"/>
+            <a:r>
+              <a:rPr/>
+              <a:t>Schema validation reduces malformed output risk but is not a complete prompt-injection defence</a:t>
+            </a:r>
+          </a:p>
         </p:txBody>
       </p:sp>
     </p:spTree>
@@ -4307,6 +4361,19 @@
             <a:r>
               <a:rPr/>
               <a:t>Offline fixture makes regression tests independent of network and model availability</a:t>
+            </a:r>
+          </a:p>
+          <a:p>
+            <a:pPr lvl="0" indent="0" marL="0">
+              <a:buNone/>
+            </a:pPr>
+            <a:r>
+              <a:rPr b="1"/>
+              <a:t>Pass criteria:</a:t>
+            </a:r>
+            <a:r>
+              <a:rPr/>
+              <a:t> 2-5 valid tasks; no more than 3 cycles; deterministic fallback; duplicate suppression; exactly 3 output files.</a:t>
             </a:r>
           </a:p>
           <a:p>

</xml_diff>